<commit_message>
Update presentation materials for "Khai thác các mẫu hiếm" with revised slides, speaker notes, and new PPTX versions; enhance content clarity and accuracy.
</commit_message>
<xml_diff>
--- a/slides/presentation.pptx
+++ b/slides/presentation.pptx
@@ -798,7 +798,7 @@
           <a:lstStyle/>
           <a:p>
             <a:r>
-              <a:t>Kiểm chứng tự động đủ chặt để bắt được lỗi của chính tài liệu gốc. (1:00)</a:t>
+              <a:t>19 assert phủ toàn bộ: bảng FIM, ba thuật toán, bond, all-confidence, TID/DTID-List — tất cả khớp kết quả tính tay trên ví dụ minh họa. (1:00)</a:t>
             </a:r>
           </a:p>
         </p:txBody>
@@ -5242,22 +5242,7 @@
               </a:defRPr>
             </a:pPr>
             <a:r>
-              <a:t>• 19 assert đối chiếu từng con số bài giảng — 100% ĐẠT</a:t>
-            </a:r>
-          </a:p>
-          <a:p>
-            <a:pPr>
-              <a:spcAft>
-                <a:spcPts val="1200"/>
-              </a:spcAft>
-              <a:defRPr sz="2000" b="1">
-                <a:solidFill>
-                  <a:srgbClr val="1E1E1E"/>
-                </a:solidFill>
-              </a:defRPr>
-            </a:pPr>
-            <a:r>
-              <a:t>• Phát hiện thiếu sót trong slide gốc: FIM liệt kê 10, đúng là 11</a:t>
+              <a:t>• 19 assert đối chiếu từng con số kỳ vọng trên ví dụ — 100% ĐẠT</a:t>
             </a:r>
           </a:p>
           <a:p>
@@ -5272,7 +5257,7 @@
               </a:defRPr>
             </a:pPr>
             <a:r>
-              <a:t>   – (sót {pasta, orange, cake}, sup = 2)</a:t>
+              <a:t>• Phủ FIM, AprioriRare, AprioriInverse, CORI &amp; các độ đo</a:t>
             </a:r>
           </a:p>
           <a:p>
@@ -6248,7 +6233,7 @@
               </a:defRPr>
             </a:pPr>
             <a:r>
-              <a:t>Ví dụ chạy xuyên suốt</a:t>
+              <a:t>Ví dụ</a:t>
             </a:r>
           </a:p>
         </p:txBody>

</xml_diff>

<commit_message>
Add overview slide and enhance presentation structure
- Introduced a new slide detailing the flow of the problem using the running example, including a TikZ diagram for clarity.
- Updated existing slides to reflect the new structure and ensure smooth transitions between topics.
- Adjusted slide numbering and titles for consistency.
- Modified LaTeX code to include necessary packages for diagram rendering.
- Updated PowerPoint files to include the new slide and changes made in the presentation.
</commit_message>
<xml_diff>
--- a/slides/presentation.pptx
+++ b/slides/presentation.pptx
@@ -22,6 +22,7 @@
     <p:sldId id="270" r:id="rId22"/>
     <p:sldId id="271" r:id="rId23"/>
     <p:sldId id="272" r:id="rId24"/>
+    <p:sldId id="273" r:id="rId25"/>
   </p:sldIdLst>
   <p:sldSz cx="12188952" cy="6858000" type="screen4x3"/>
   <p:notesSz cx="6858000" cy="9144000"/>
@@ -588,7 +589,7 @@
           <a:lstStyle/>
           <a:p>
             <a:r>
-              <a:t>Nhấn tính anti-monotone — CORI dùng nó để cắt tỉa cả nhánh. (1:00)</a:t>
+              <a:t>Chuyển mạch sang nửa sau: hiếm thôi chưa đủ, còn cần 'thật'. (0:45)</a:t>
             </a:r>
           </a:p>
         </p:txBody>
@@ -658,7 +659,7 @@
           <a:lstStyle/>
           <a:p>
             <a:r>
-              <a:t>Mẫu hiếm chỉ chạm phần rất nhỏ dữ liệu, còn lại toàn null transactions — độ đo nhạy với chúng bị bóp méo trên dữ liệu thưa. (0:45)</a:t>
+              <a:t>Nhấn tính anti-monotone — CORI dùng nó để cắt tỉa cả nhánh. (1:00)</a:t>
             </a:r>
           </a:p>
         </p:txBody>
@@ -728,7 +729,7 @@
           <a:lstStyle/>
           <a:p>
             <a:r>
-              <a:t>Khi nối hai itemset: TID-List lấy giao, DTID-List lấy hợp — support và bond tính ngay. Nút chưa hiếm vẫn phải mở rộng. (1:15)</a:t>
+              <a:t>Mẫu hiếm chỉ chạm phần rất nhỏ dữ liệu, còn lại toàn null transactions — độ đo nhạy với chúng bị bóp méo trên dữ liệu thưa. (0:45)</a:t>
             </a:r>
           </a:p>
         </p:txBody>
@@ -798,7 +799,7 @@
           <a:lstStyle/>
           <a:p>
             <a:r>
-              <a:t>19 assert phủ toàn bộ: bảng FIM, ba thuật toán, bond, all-confidence, TID/DTID-List — tất cả khớp kết quả tính tay trên ví dụ minh họa. (1:00)</a:t>
+              <a:t>Khi nối hai itemset: TID-List lấy giao, DTID-List lấy hợp — support và bond tính ngay. Nút chưa hiếm vẫn phải mở rộng. (1:15)</a:t>
             </a:r>
           </a:p>
         </p:txBody>
@@ -868,7 +869,7 @@
           <a:lstStyle/>
           <a:p>
             <a:r>
-              <a:t>Thời gian AprioriRare tăng theo cấp mũ khi minsup giảm. mRI gọn nhưng chi phí bị chi phối bởi vùng phổ biến. (1:00)</a:t>
+              <a:t>19 assert phủ toàn bộ: bảng FIM, ba thuật toán, bond, all-confidence, TID/DTID-List — tất cả khớp kết quả tính tay trên ví dụ minh họa. (1:00)</a:t>
             </a:r>
           </a:p>
         </p:txBody>
@@ -938,7 +939,7 @@
           <a:lstStyle/>
           <a:p>
             <a:r>
-              <a:t>Mẫu đắt giá nhất: 36 cây nấm mùi mốc luôn đồng thời không vòng cuống + cuống màu quế — bond = 1 tuyệt đối, FIM không bao giờ chạm tới. (1:15)</a:t>
+              <a:t>Thời gian AprioriRare tăng theo cấp mũ khi minsup giảm. mRI gọn nhưng chi phí bị chi phối bởi vùng phổ biến. (1:00)</a:t>
             </a:r>
           </a:p>
         </p:txBody>
@@ -1008,7 +1009,7 @@
           <a:lstStyle/>
           <a:p>
             <a:r>
-              <a:t>Thông điệp: không có định nghĩa hiếm 'đúng' duy nhất — chỉ có đánh đổi; null-invariance là bắt buộc trên dữ liệu thưa. (0:50)</a:t>
+              <a:t>Mẫu đắt giá nhất: 36 cây nấm mùi mốc luôn đồng thời không vòng cuống + cuống màu quế — bond = 1 tuyệt đối, FIM không bao giờ chạm tới. (1:15)</a:t>
             </a:r>
           </a:p>
         </p:txBody>
@@ -1078,6 +1079,76 @@
           <a:lstStyle/>
           <a:p>
             <a:r>
+              <a:t>Thông điệp: không có định nghĩa hiếm 'đúng' duy nhất — chỉ có đánh đổi; null-invariance là bắt buộc trên dữ liệu thưa. (0:50)</a:t>
+            </a:r>
+          </a:p>
+        </p:txBody>
+      </p:sp>
+      <p:sp>
+        <p:nvSpPr>
+          <p:cNvPr id="4" name="Slide Number Placeholder 3"/>
+          <p:cNvSpPr>
+            <a:spLocks noGrp="1"/>
+          </p:cNvSpPr>
+          <p:nvPr>
+            <p:ph type="sldNum" idx="5" sz="quarter"/>
+          </p:nvPr>
+        </p:nvSpPr>
+        <p:spPr/>
+      </p:sp>
+    </p:spTree>
+  </p:cSld>
+  <p:clrMapOvr>
+    <a:masterClrMapping/>
+  </p:clrMapOvr>
+</p:notes>
+</file>
+
+<file path=ppt/notesSlides/notesSlide18.xml><?xml version="1.0" encoding="utf-8"?>
+<p:notes xmlns:a="http://schemas.openxmlformats.org/drawingml/2006/main" xmlns:p="http://schemas.openxmlformats.org/presentationml/2006/main" xmlns:r="http://schemas.openxmlformats.org/officeDocument/2006/relationships">
+  <p:cSld>
+    <p:spTree>
+      <p:nvGrpSpPr>
+        <p:cNvPr id="1" name=""/>
+        <p:cNvGrpSpPr/>
+        <p:nvPr/>
+      </p:nvGrpSpPr>
+      <p:grpSpPr>
+        <a:xfrm>
+          <a:off x="0" y="0"/>
+          <a:ext cx="0" cy="0"/>
+          <a:chOff x="0" y="0"/>
+          <a:chExt cx="0" cy="0"/>
+        </a:xfrm>
+      </p:grpSpPr>
+      <p:sp>
+        <p:nvSpPr>
+          <p:cNvPr id="2" name="Slide Image Placeholder 1"/>
+          <p:cNvSpPr>
+            <a:spLocks noGrp="1"/>
+          </p:cNvSpPr>
+          <p:nvPr>
+            <p:ph type="sldImg" idx="2"/>
+          </p:nvPr>
+        </p:nvSpPr>
+        <p:spPr/>
+      </p:sp>
+      <p:sp>
+        <p:nvSpPr>
+          <p:cNvPr id="3" name="Notes Placeholder 2"/>
+          <p:cNvSpPr>
+            <a:spLocks noGrp="1"/>
+          </p:cNvSpPr>
+          <p:nvPr>
+            <p:ph type="body" idx="3" sz="quarter"/>
+          </p:nvPr>
+        </p:nvSpPr>
+        <p:spPr/>
+        <p:txBody>
+          <a:bodyPr/>
+          <a:lstStyle/>
+          <a:p>
+            <a:r>
               <a:t>Cảm ơn, mời câu hỏi. Chuẩn bị sẵn Q&amp;A trong TALK_SCRIPT.md. (0:20)</a:t>
             </a:r>
           </a:p>
@@ -1428,7 +1499,7 @@
           <a:lstStyle/>
           <a:p>
             <a:r>
-              <a:t>Tâm điểm lý thuyết — hình ảnh 'đường biên' trong dàn itemset. mRI nhỏ gọn mà đại diện mọi mẫu hiếm; PRI thêm ngưỡng dưới loại nhiễu. (1:15)</a:t>
+              <a:t>Bản đồ toàn bài trên ví dụ 4 giao dịch: từ CSDL thô → định nghĩa hiếm (minsup) → thuật toán khai thác → độ đo lọc mẫu giả → CORI. Khán giả định vị được mình đang ở khối nào trong suốt phần còn lại. (0:40)</a:t>
             </a:r>
           </a:p>
         </p:txBody>
@@ -1498,7 +1569,7 @@
           <a:lstStyle/>
           <a:p>
             <a:r>
-              <a:t>Qua prune nghĩa là mọi tập con đều phổ biến → không phổ biến là tự động thành mRI. Nhược điểm chi phí định lượng ở Exp A. (1:15)</a:t>
+              <a:t>Tâm điểm lý thuyết — hình ảnh 'đường biên' trong dàn itemset. mRI nhỏ gọn mà đại diện mọi mẫu hiếm; PRI thêm ngưỡng dưới loại nhiễu. (1:15)</a:t>
             </a:r>
           </a:p>
         </p:txBody>
@@ -1568,7 +1639,7 @@
           <a:lstStyle/>
           <a:p>
             <a:r>
-              <a:t>Không gian nhỏ hơn hẳn; cái giá là bỏ sót mẫu lai như {bệnh hiếm + triệu chứng phổ biến}. (1:00)</a:t>
+              <a:t>Qua prune nghĩa là mọi tập con đều phổ biến → không phổ biến là tự động thành mRI. Nhược điểm chi phí định lượng ở Exp A. (1:15)</a:t>
             </a:r>
           </a:p>
         </p:txBody>
@@ -1638,7 +1709,7 @@
           <a:lstStyle/>
           <a:p>
             <a:r>
-              <a:t>Chuyển mạch sang nửa sau: hiếm thôi chưa đủ, còn cần 'thật'. (0:45)</a:t>
+              <a:t>Không gian nhỏ hơn hẳn; cái giá là bỏ sót mẫu lai như {bệnh hiếm + triệu chứng phổ biến}. (1:00)</a:t>
             </a:r>
           </a:p>
         </p:txBody>
@@ -4751,7 +4822,7 @@
               </a:defRPr>
             </a:pPr>
             <a:r>
-              <a:t>Hai độ đo: bond và all-confidence</a:t>
+              <a:t>Mẫu giả: phổ biến ≠ đáng tin</a:t>
             </a:r>
           </a:p>
         </p:txBody>
@@ -4782,29 +4853,14 @@
               <a:spcAft>
                 <a:spcPts val="1200"/>
               </a:spcAft>
-              <a:defRPr sz="2000" b="0">
+              <a:defRPr sz="2000" b="1">
                 <a:solidFill>
                   <a:srgbClr val="1E1E1E"/>
                 </a:solidFill>
               </a:defRPr>
             </a:pPr>
             <a:r>
-              <a:t>• bond(X) = sup(X) / dsup(X) — tỉ lệ giao dịch 'liên quan' chứa toàn bộ X</a:t>
-            </a:r>
-          </a:p>
-          <a:p>
-            <a:pPr>
-              <a:spcAft>
-                <a:spcPts val="1200"/>
-              </a:spcAft>
-              <a:defRPr sz="2000" b="1">
-                <a:solidFill>
-                  <a:srgbClr val="1E1E1E"/>
-                </a:solidFill>
-              </a:defRPr>
-            </a:pPr>
-            <a:r>
-              <a:t>• bond = 1: các mục luôn đi cùng nhau</a:t>
+              <a:t>• {pasta, cake} xuất hiện ở 50% giao dịch</a:t>
             </a:r>
           </a:p>
           <a:p>
@@ -4819,22 +4875,7 @@
               </a:defRPr>
             </a:pPr>
             <a:r>
-              <a:t>• allconf(X) = sup(X) / max sup(item) — confidence nhỏ nhất của mọi luật từ X</a:t>
-            </a:r>
-          </a:p>
-          <a:p>
-            <a:pPr>
-              <a:spcAft>
-                <a:spcPts val="1200"/>
-              </a:spcAft>
-              <a:defRPr sz="2000" b="1">
-                <a:solidFill>
-                  <a:srgbClr val="2563EB"/>
-                </a:solidFill>
-              </a:defRPr>
-            </a:pPr>
-            <a:r>
-              <a:t>• Cả hai: = 1 với itemset đơn; anti-monotone → cắt tỉa kiểu Apriori</a:t>
+              <a:t>• Nhưng pasta có mặt trong mọi giao dịch</a:t>
             </a:r>
           </a:p>
           <a:p>
@@ -4844,12 +4885,27 @@
               </a:spcAft>
               <a:defRPr sz="2000" b="0">
                 <a:solidFill>
-                  <a:srgbClr val="1E1E1E"/>
-                </a:solidFill>
-              </a:defRPr>
-            </a:pPr>
-            <a:r>
-              <a:t>• Ví dụ: bond({cake, bread}) = 0   •   bond({pasta, orange}) = 3/4</a:t>
+                  <a:srgbClr val="DC2626"/>
+                </a:solidFill>
+              </a:defRPr>
+            </a:pPr>
+            <a:r>
+              <a:t>• Đồng xuất hiện là tất yếu — không có liên hệ thật (spurious)</a:t>
+            </a:r>
+          </a:p>
+          <a:p>
+            <a:pPr>
+              <a:spcAft>
+                <a:spcPts val="1200"/>
+              </a:spcAft>
+              <a:defRPr sz="2000" b="0">
+                <a:solidFill>
+                  <a:srgbClr val="2563EB"/>
+                </a:solidFill>
+              </a:defRPr>
+            </a:pPr>
+            <a:r>
+              <a:t>• Cần độ đo tương quan để lọc</a:t>
             </a:r>
           </a:p>
         </p:txBody>
@@ -4902,7 +4958,7 @@
               </a:defRPr>
             </a:pPr>
             <a:r>
-              <a:t>Null-invariance: vì sao lift thất bại</a:t>
+              <a:t>Hai độ đo: bond và all-confidence</a:t>
             </a:r>
           </a:p>
         </p:txBody>
@@ -4940,7 +4996,22 @@
               </a:defRPr>
             </a:pPr>
             <a:r>
-              <a:t>• Null transaction: giao dịch không chứa mục nào của mẫu</a:t>
+              <a:t>• bond(X) = sup(X) / dsup(X) — tỉ lệ giao dịch 'liên quan' chứa toàn bộ X</a:t>
+            </a:r>
+          </a:p>
+          <a:p>
+            <a:pPr>
+              <a:spcAft>
+                <a:spcPts val="1200"/>
+              </a:spcAft>
+              <a:defRPr sz="2000" b="1">
+                <a:solidFill>
+                  <a:srgbClr val="1E1E1E"/>
+                </a:solidFill>
+              </a:defRPr>
+            </a:pPr>
+            <a:r>
+              <a:t>• bond = 1: các mục luôn đi cùng nhau</a:t>
             </a:r>
           </a:p>
           <a:p>
@@ -4950,12 +5021,12 @@
               </a:spcAft>
               <a:defRPr sz="2000" b="0">
                 <a:solidFill>
-                  <a:srgbClr val="DC2626"/>
-                </a:solidFill>
-              </a:defRPr>
-            </a:pPr>
-            <a:r>
-              <a:t>• χ², lift bị bóp méo bởi hàng triệu giao dịch không liên quan</a:t>
+                  <a:srgbClr val="1E1E1E"/>
+                </a:solidFill>
+              </a:defRPr>
+            </a:pPr>
+            <a:r>
+              <a:t>• allconf(X) = sup(X) / max sup(item) — confidence nhỏ nhất của mọi luật từ X</a:t>
             </a:r>
           </a:p>
           <a:p>
@@ -4965,12 +5036,12 @@
               </a:spcAft>
               <a:defRPr sz="2000" b="1">
                 <a:solidFill>
-                  <a:srgbClr val="1E1E1E"/>
-                </a:solidFill>
-              </a:defRPr>
-            </a:pPr>
-            <a:r>
-              <a:t>• bond, all-confidence, cosine, Kulczynski: null-invariant</a:t>
+                  <a:srgbClr val="2563EB"/>
+                </a:solidFill>
+              </a:defRPr>
+            </a:pPr>
+            <a:r>
+              <a:t>• Cả hai: = 1 với itemset đơn; anti-monotone → cắt tỉa kiểu Apriori</a:t>
             </a:r>
           </a:p>
           <a:p>
@@ -4978,14 +5049,14 @@
               <a:spcAft>
                 <a:spcPts val="1200"/>
               </a:spcAft>
-              <a:defRPr sz="2000" b="1">
-                <a:solidFill>
-                  <a:srgbClr val="2563EB"/>
-                </a:solidFill>
-              </a:defRPr>
-            </a:pPr>
-            <a:r>
-              <a:t>• Mẫu hiếm ⊂ phần rất nhỏ dữ liệu → bắt buộc dùng null-invariant</a:t>
+              <a:defRPr sz="2000" b="0">
+                <a:solidFill>
+                  <a:srgbClr val="1E1E1E"/>
+                </a:solidFill>
+              </a:defRPr>
+            </a:pPr>
+            <a:r>
+              <a:t>• Ví dụ: bond({cake, bread}) = 0   •   bond({pasta, orange}) = 3/4</a:t>
             </a:r>
           </a:p>
         </p:txBody>
@@ -5038,7 +5109,7 @@
               </a:defRPr>
             </a:pPr>
             <a:r>
-              <a:t>CORI: hiếm + tương quan trong một lần duyệt</a:t>
+              <a:t>Null-invariance: vì sao lift thất bại</a:t>
             </a:r>
           </a:p>
         </p:txBody>
@@ -5069,14 +5140,14 @@
               <a:spcAft>
                 <a:spcPts val="1200"/>
               </a:spcAft>
-              <a:defRPr sz="2000" b="1">
+              <a:defRPr sz="2000" b="0">
                 <a:solidFill>
                   <a:srgbClr val="1E1E1E"/>
                 </a:solidFill>
               </a:defRPr>
             </a:pPr>
             <a:r>
-              <a:t>• Rare correlated: sup(X) &lt; maxsup VÀ bond(X) ≥ minbond</a:t>
+              <a:t>• Null transaction: giao dịch không chứa mục nào của mẫu</a:t>
             </a:r>
           </a:p>
           <a:p>
@@ -5086,12 +5157,12 @@
               </a:spcAft>
               <a:defRPr sz="2000" b="0">
                 <a:solidFill>
-                  <a:srgbClr val="1E1E1E"/>
-                </a:solidFill>
-              </a:defRPr>
-            </a:pPr>
-            <a:r>
-              <a:t>• Hai ràng buộc đối ngẫu: hiếm = monotone • bond = anti-monotone</a:t>
+                  <a:srgbClr val="DC2626"/>
+                </a:solidFill>
+              </a:defRPr>
+            </a:pPr>
+            <a:r>
+              <a:t>• χ², lift bị bóp méo bởi hàng triệu giao dịch không liên quan</a:t>
             </a:r>
           </a:p>
           <a:p>
@@ -5099,14 +5170,14 @@
               <a:spcAft>
                 <a:spcPts val="1200"/>
               </a:spcAft>
-              <a:defRPr sz="2000" b="0">
+              <a:defRPr sz="2000" b="1">
                 <a:solidFill>
                   <a:srgbClr val="1E1E1E"/>
                 </a:solidFill>
               </a:defRPr>
             </a:pPr>
             <a:r>
-              <a:t>• Duyệt kiểu Eclat, mỗi itemset giữ TID-List + DTID-List</a:t>
+              <a:t>• bond, all-confidence, cosine, Kulczynski: null-invariant</a:t>
             </a:r>
           </a:p>
           <a:p>
@@ -5114,29 +5185,14 @@
               <a:spcAft>
                 <a:spcPts val="1200"/>
               </a:spcAft>
-              <a:defRPr sz="2000" b="0">
-                <a:solidFill>
-                  <a:srgbClr val="1E1E1E"/>
-                </a:solidFill>
-              </a:defRPr>
-            </a:pPr>
-            <a:r>
-              <a:t>• bond rớt ngưỡng → cắt cả nhánh; sup ≥ maxsup → chưa xuất nhưng vẫn mở rộng</a:t>
-            </a:r>
-          </a:p>
-          <a:p>
-            <a:pPr>
-              <a:spcAft>
-                <a:spcPts val="1200"/>
-              </a:spcAft>
-              <a:defRPr sz="2000" b="0">
-                <a:solidFill>
-                  <a:srgbClr val="059669"/>
-                </a:solidFill>
-              </a:defRPr>
-            </a:pPr>
-            <a:r>
-              <a:t>• Ví dụ (3, 0.6): {bread}, {cake}, {orange, cake}  ✓ khớp bài giảng</a:t>
+              <a:defRPr sz="2000" b="1">
+                <a:solidFill>
+                  <a:srgbClr val="2563EB"/>
+                </a:solidFill>
+              </a:defRPr>
+            </a:pPr>
+            <a:r>
+              <a:t>• Mẫu hiếm ⊂ phần rất nhỏ dữ liệu → bắt buộc dùng null-invariant</a:t>
             </a:r>
           </a:p>
         </p:txBody>
@@ -5189,7 +5245,7 @@
               </a:defRPr>
             </a:pPr>
             <a:r>
-              <a:t>Cài đặt &amp; kiểm chứng 100%</a:t>
+              <a:t>CORI: hiếm + tương quan trong một lần duyệt</a:t>
             </a:r>
           </a:p>
         </p:txBody>
@@ -5220,29 +5276,14 @@
               <a:spcAft>
                 <a:spcPts val="1200"/>
               </a:spcAft>
-              <a:defRPr sz="2000" b="0">
+              <a:defRPr sz="2000" b="1">
                 <a:solidFill>
                   <a:srgbClr val="1E1E1E"/>
                 </a:solidFill>
               </a:defRPr>
             </a:pPr>
             <a:r>
-              <a:t>• Python 3.13, chỉ thư viện chuẩn; TID-set dùng chung cho cả 3 thuật toán</a:t>
-            </a:r>
-          </a:p>
-          <a:p>
-            <a:pPr>
-              <a:spcAft>
-                <a:spcPts val="1200"/>
-              </a:spcAft>
-              <a:defRPr sz="2000" b="1">
-                <a:solidFill>
-                  <a:srgbClr val="059669"/>
-                </a:solidFill>
-              </a:defRPr>
-            </a:pPr>
-            <a:r>
-              <a:t>• 19 assert đối chiếu từng con số kỳ vọng trên ví dụ — 100% ĐẠT</a:t>
+              <a:t>• Rare correlated: sup(X) &lt; maxsup VÀ bond(X) ≥ minbond</a:t>
             </a:r>
           </a:p>
           <a:p>
@@ -5257,7 +5298,7 @@
               </a:defRPr>
             </a:pPr>
             <a:r>
-              <a:t>• Phủ FIM, AprioriRare, AprioriInverse, CORI &amp; các độ đo</a:t>
+              <a:t>• Hai ràng buộc đối ngẫu: hiếm = monotone • bond = anti-monotone</a:t>
             </a:r>
           </a:p>
           <a:p>
@@ -5272,7 +5313,37 @@
               </a:defRPr>
             </a:pPr>
             <a:r>
-              <a:t>• {pasta, cake}: lift = 1.0, bond = 0.5 → xác nhận mẫu giả bằng số</a:t>
+              <a:t>• Duyệt kiểu Eclat, mỗi itemset giữ TID-List + DTID-List</a:t>
+            </a:r>
+          </a:p>
+          <a:p>
+            <a:pPr>
+              <a:spcAft>
+                <a:spcPts val="1200"/>
+              </a:spcAft>
+              <a:defRPr sz="2000" b="0">
+                <a:solidFill>
+                  <a:srgbClr val="1E1E1E"/>
+                </a:solidFill>
+              </a:defRPr>
+            </a:pPr>
+            <a:r>
+              <a:t>• bond rớt ngưỡng → cắt cả nhánh; sup ≥ maxsup → chưa xuất nhưng vẫn mở rộng</a:t>
+            </a:r>
+          </a:p>
+          <a:p>
+            <a:pPr>
+              <a:spcAft>
+                <a:spcPts val="1200"/>
+              </a:spcAft>
+              <a:defRPr sz="2000" b="0">
+                <a:solidFill>
+                  <a:srgbClr val="059669"/>
+                </a:solidFill>
+              </a:defRPr>
+            </a:pPr>
+            <a:r>
+              <a:t>• Ví dụ (3, 0.6): {bread}, {cake}, {orange, cake}  ✓ khớp bài giảng</a:t>
             </a:r>
           </a:p>
         </p:txBody>
@@ -5286,6 +5357,142 @@
 </file>
 
 <file path=ppt/slides/slide14.xml><?xml version="1.0" encoding="utf-8"?>
+<p:sld xmlns:a="http://schemas.openxmlformats.org/drawingml/2006/main" xmlns:p="http://schemas.openxmlformats.org/presentationml/2006/main" xmlns:r="http://schemas.openxmlformats.org/officeDocument/2006/relationships">
+  <p:cSld>
+    <p:spTree>
+      <p:nvGrpSpPr>
+        <p:cNvPr id="1" name=""/>
+        <p:cNvGrpSpPr/>
+        <p:nvPr/>
+      </p:nvGrpSpPr>
+      <p:grpSpPr/>
+      <p:sp>
+        <p:nvSpPr>
+          <p:cNvPr id="2" name="TextBox 1"/>
+          <p:cNvSpPr txBox="1"/>
+          <p:nvPr/>
+        </p:nvSpPr>
+        <p:spPr>
+          <a:xfrm>
+            <a:off x="548640" y="320040"/>
+            <a:ext cx="11064240" cy="822960"/>
+          </a:xfrm>
+          <a:prstGeom prst="rect">
+            <a:avLst/>
+          </a:prstGeom>
+          <a:noFill/>
+        </p:spPr>
+        <p:txBody>
+          <a:bodyPr wrap="none">
+            <a:spAutoFit/>
+          </a:bodyPr>
+          <a:lstStyle/>
+          <a:p>
+            <a:pPr>
+              <a:defRPr sz="3000" b="1">
+                <a:solidFill>
+                  <a:srgbClr val="8B5CF6"/>
+                </a:solidFill>
+              </a:defRPr>
+            </a:pPr>
+            <a:r>
+              <a:t>Cài đặt &amp; kiểm chứng 100%</a:t>
+            </a:r>
+          </a:p>
+        </p:txBody>
+      </p:sp>
+      <p:sp>
+        <p:nvSpPr>
+          <p:cNvPr id="3" name="TextBox 2"/>
+          <p:cNvSpPr txBox="1"/>
+          <p:nvPr/>
+        </p:nvSpPr>
+        <p:spPr>
+          <a:xfrm>
+            <a:off x="731520" y="1280160"/>
+            <a:ext cx="10698480" cy="5120640"/>
+          </a:xfrm>
+          <a:prstGeom prst="rect">
+            <a:avLst/>
+          </a:prstGeom>
+          <a:noFill/>
+        </p:spPr>
+        <p:txBody>
+          <a:bodyPr wrap="square">
+            <a:spAutoFit/>
+          </a:bodyPr>
+          <a:lstStyle/>
+          <a:p>
+            <a:pPr>
+              <a:spcAft>
+                <a:spcPts val="1200"/>
+              </a:spcAft>
+              <a:defRPr sz="2000" b="0">
+                <a:solidFill>
+                  <a:srgbClr val="1E1E1E"/>
+                </a:solidFill>
+              </a:defRPr>
+            </a:pPr>
+            <a:r>
+              <a:t>• Python 3.13, chỉ thư viện chuẩn; TID-set dùng chung cho cả 3 thuật toán</a:t>
+            </a:r>
+          </a:p>
+          <a:p>
+            <a:pPr>
+              <a:spcAft>
+                <a:spcPts val="1200"/>
+              </a:spcAft>
+              <a:defRPr sz="2000" b="1">
+                <a:solidFill>
+                  <a:srgbClr val="059669"/>
+                </a:solidFill>
+              </a:defRPr>
+            </a:pPr>
+            <a:r>
+              <a:t>• 19 assert đối chiếu từng con số kỳ vọng trên ví dụ — 100% ĐẠT</a:t>
+            </a:r>
+          </a:p>
+          <a:p>
+            <a:pPr>
+              <a:spcAft>
+                <a:spcPts val="1200"/>
+              </a:spcAft>
+              <a:defRPr sz="2000" b="0">
+                <a:solidFill>
+                  <a:srgbClr val="1E1E1E"/>
+                </a:solidFill>
+              </a:defRPr>
+            </a:pPr>
+            <a:r>
+              <a:t>• Phủ FIM, AprioriRare, AprioriInverse, CORI &amp; các độ đo</a:t>
+            </a:r>
+          </a:p>
+          <a:p>
+            <a:pPr>
+              <a:spcAft>
+                <a:spcPts val="1200"/>
+              </a:spcAft>
+              <a:defRPr sz="2000" b="0">
+                <a:solidFill>
+                  <a:srgbClr val="1E1E1E"/>
+                </a:solidFill>
+              </a:defRPr>
+            </a:pPr>
+            <a:r>
+              <a:t>• {pasta, cake}: lift = 1.0, bond = 0.5 → xác nhận mẫu giả bằng số</a:t>
+            </a:r>
+          </a:p>
+        </p:txBody>
+      </p:sp>
+    </p:spTree>
+  </p:cSld>
+  <p:clrMapOvr>
+    <a:masterClrMapping/>
+  </p:clrMapOvr>
+</p:sld>
+</file>
+
+<file path=ppt/slides/slide15.xml><?xml version="1.0" encoding="utf-8"?>
 <p:sld xmlns:a="http://schemas.openxmlformats.org/drawingml/2006/main" xmlns:p="http://schemas.openxmlformats.org/presentationml/2006/main" xmlns:r="http://schemas.openxmlformats.org/officeDocument/2006/relationships">
   <p:cSld>
     <p:spTree>
@@ -5415,7 +5622,7 @@
 </p:sld>
 </file>
 
-<file path=ppt/slides/slide15.xml><?xml version="1.0" encoding="utf-8"?>
+<file path=ppt/slides/slide16.xml><?xml version="1.0" encoding="utf-8"?>
 <p:sld xmlns:a="http://schemas.openxmlformats.org/drawingml/2006/main" xmlns:p="http://schemas.openxmlformats.org/presentationml/2006/main" xmlns:r="http://schemas.openxmlformats.org/officeDocument/2006/relationships">
   <p:cSld>
     <p:spTree>
@@ -5545,7 +5752,7 @@
 </p:sld>
 </file>
 
-<file path=ppt/slides/slide16.xml><?xml version="1.0" encoding="utf-8"?>
+<file path=ppt/slides/slide17.xml><?xml version="1.0" encoding="utf-8"?>
 <p:sld xmlns:a="http://schemas.openxmlformats.org/drawingml/2006/main" xmlns:p="http://schemas.openxmlformats.org/presentationml/2006/main" xmlns:r="http://schemas.openxmlformats.org/officeDocument/2006/relationships">
   <p:cSld>
     <p:spTree>
@@ -5681,7 +5888,7 @@
 </p:sld>
 </file>
 
-<file path=ppt/slides/slide17.xml><?xml version="1.0" encoding="utf-8"?>
+<file path=ppt/slides/slide18.xml><?xml version="1.0" encoding="utf-8"?>
 <p:sld xmlns:a="http://schemas.openxmlformats.org/drawingml/2006/main" xmlns:p="http://schemas.openxmlformats.org/presentationml/2006/main" xmlns:r="http://schemas.openxmlformats.org/officeDocument/2006/relationships">
   <p:cSld>
     <p:spTree>
@@ -6399,7 +6606,7 @@
               </a:defRPr>
             </a:pPr>
             <a:r>
-              <a:t>Ba định nghĩa mẫu hiếm</a:t>
+              <a:t>Toàn cảnh: dòng chảy bài toán trên ví dụ</a:t>
             </a:r>
           </a:p>
         </p:txBody>
@@ -6430,6 +6637,21 @@
               <a:spcAft>
                 <a:spcPts val="1200"/>
               </a:spcAft>
+              <a:defRPr sz="2000" b="1">
+                <a:solidFill>
+                  <a:srgbClr val="2563EB"/>
+                </a:solidFill>
+              </a:defRPr>
+            </a:pPr>
+            <a:r>
+              <a:t>• CSDL 4 giao dịch —[minsup]→ Khai thác mẫu hiếm —[minbond]→ Lọc tương quan → CORI</a:t>
+            </a:r>
+          </a:p>
+          <a:p>
+            <a:pPr>
+              <a:spcAft>
+                <a:spcPts val="1200"/>
+              </a:spcAft>
               <a:defRPr sz="2000" b="0">
                 <a:solidFill>
                   <a:srgbClr val="1E1E1E"/>
@@ -6437,7 +6659,22 @@
               </a:defRPr>
             </a:pPr>
             <a:r>
-              <a:t>• Infrequent: sup &lt; minsup — bùng nổ, chứa cả sup = 0</a:t>
+              <a:t>• Bước 1 — khai thác hiếm: AprioriRare → mRI = {bread}, {lemon, cake}; AprioriInverse → PRI = {bread}, …</a:t>
+            </a:r>
+          </a:p>
+          <a:p>
+            <a:pPr>
+              <a:spcAft>
+                <a:spcPts val="1200"/>
+              </a:spcAft>
+              <a:defRPr sz="2000" b="0">
+                <a:solidFill>
+                  <a:srgbClr val="DC2626"/>
+                </a:solidFill>
+              </a:defRPr>
+            </a:pPr>
+            <a:r>
+              <a:t>• Bước 2 — lọc mẫu giả: loại {pasta, cake} vì lift = 1, bond = 0.5 (đi cùng nhau chỉ do pasta có mặt khắp nơi)</a:t>
             </a:r>
           </a:p>
           <a:p>
@@ -6447,12 +6684,12 @@
               </a:spcAft>
               <a:defRPr sz="2000" b="1">
                 <a:solidFill>
-                  <a:srgbClr val="1E1E1E"/>
-                </a:solidFill>
-              </a:defRPr>
-            </a:pPr>
-            <a:r>
-              <a:t>• Minimal rare (mRI): hiếm, mọi tập con đều phổ biến</a:t>
+                  <a:srgbClr val="059669"/>
+                </a:solidFill>
+              </a:defRPr>
+            </a:pPr>
+            <a:r>
+              <a:t>• Kết quả CORI: {bread}, {cake}, {orange, cake} — vừa hiếm vừa thật sự gắn kết</a:t>
             </a:r>
           </a:p>
           <a:p>
@@ -6462,42 +6699,12 @@
               </a:spcAft>
               <a:defRPr sz="2000" b="0">
                 <a:solidFill>
-                  <a:srgbClr val="2563EB"/>
-                </a:solidFill>
-              </a:defRPr>
-            </a:pPr>
-            <a:r>
-              <a:t>   – → biên dưới của vùng hiếm trong dàn itemset</a:t>
-            </a:r>
-          </a:p>
-          <a:p>
-            <a:pPr>
-              <a:spcAft>
-                <a:spcPts val="1200"/>
-              </a:spcAft>
-              <a:defRPr sz="2000" b="1">
-                <a:solidFill>
                   <a:srgbClr val="1E1E1E"/>
                 </a:solidFill>
               </a:defRPr>
             </a:pPr>
             <a:r>
-              <a:t>• Perfectly rare (PRI): minsup ≤ sup &lt; maxsup, mọi item thành phần đều hiếm</a:t>
-            </a:r>
-          </a:p>
-          <a:p>
-            <a:pPr>
-              <a:spcAft>
-                <a:spcPts val="1200"/>
-              </a:spcAft>
-              <a:defRPr sz="2000" b="0">
-                <a:solidFill>
-                  <a:srgbClr val="1E1E1E"/>
-                </a:solidFill>
-              </a:defRPr>
-            </a:pPr>
-            <a:r>
-              <a:t>• Ví dụ (minsup=2): mRI = {bread}, {lemon, cake}   •   PRI = {bread}</a:t>
+              <a:t>• Các phần sau đi sâu vào từng khối trên chính ví dụ này</a:t>
             </a:r>
           </a:p>
         </p:txBody>
@@ -6550,7 +6757,7 @@
               </a:defRPr>
             </a:pPr>
             <a:r>
-              <a:t>AprioriRare: tìm biên hiếm tối thiểu</a:t>
+              <a:t>Ba định nghĩa mẫu hiếm</a:t>
             </a:r>
           </a:p>
         </p:txBody>
@@ -6588,7 +6795,7 @@
               </a:defRPr>
             </a:pPr>
             <a:r>
-              <a:t>• Duyệt theo mức (level-wise) như Apriori</a:t>
+              <a:t>• Infrequent: sup &lt; minsup — bùng nổ, chứa cả sup = 0</a:t>
             </a:r>
           </a:p>
           <a:p>
@@ -6603,7 +6810,7 @@
               </a:defRPr>
             </a:pPr>
             <a:r>
-              <a:t>• Ứng viên sống sót qua prune mà không phổ biến → chính là mRI</a:t>
+              <a:t>• Minimal rare (mRI): hiếm, mọi tập con đều phổ biến</a:t>
             </a:r>
           </a:p>
           <a:p>
@@ -6613,12 +6820,27 @@
               </a:spcAft>
               <a:defRPr sz="2000" b="0">
                 <a:solidFill>
+                  <a:srgbClr val="2563EB"/>
+                </a:solidFill>
+              </a:defRPr>
+            </a:pPr>
+            <a:r>
+              <a:t>   – → biên dưới của vùng hiếm trong dàn itemset</a:t>
+            </a:r>
+          </a:p>
+          <a:p>
+            <a:pPr>
+              <a:spcAft>
+                <a:spcPts val="1200"/>
+              </a:spcAft>
+              <a:defRPr sz="2000" b="1">
+                <a:solidFill>
                   <a:srgbClr val="1E1E1E"/>
                 </a:solidFill>
               </a:defRPr>
             </a:pPr>
             <a:r>
-              <a:t>• Itemset hiếm không dùng sinh ứng viên tiếp</a:t>
+              <a:t>• Perfectly rare (PRI): minsup ≤ sup &lt; maxsup, mọi item thành phần đều hiếm</a:t>
             </a:r>
           </a:p>
           <a:p>
@@ -6628,27 +6850,12 @@
               </a:spcAft>
               <a:defRPr sz="2000" b="0">
                 <a:solidFill>
-                  <a:srgbClr val="059669"/>
-                </a:solidFill>
-              </a:defRPr>
-            </a:pPr>
-            <a:r>
-              <a:t>• Ví dụ: mRI = {bread}, {lemon, cake}  ✓ khớp bài giảng</a:t>
-            </a:r>
-          </a:p>
-          <a:p>
-            <a:pPr>
-              <a:spcAft>
-                <a:spcPts val="1200"/>
-              </a:spcAft>
-              <a:defRPr sz="2000" b="1">
-                <a:solidFill>
-                  <a:srgbClr val="DC2626"/>
-                </a:solidFill>
-              </a:defRPr>
-            </a:pPr>
-            <a:r>
-              <a:t>• Nhược: phải duyệt toàn bộ vùng phổ biến</a:t>
+                  <a:srgbClr val="1E1E1E"/>
+                </a:solidFill>
+              </a:defRPr>
+            </a:pPr>
+            <a:r>
+              <a:t>• Ví dụ (minsup=2): mRI = {bread}, {lemon, cake}   •   PRI = {bread}</a:t>
             </a:r>
           </a:p>
         </p:txBody>
@@ -6701,7 +6908,7 @@
               </a:defRPr>
             </a:pPr>
             <a:r>
-              <a:t>AprioriInverse: thu hẹp ngay từ đầu</a:t>
+              <a:t>AprioriRare: tìm biên hiếm tối thiểu</a:t>
             </a:r>
           </a:p>
         </p:txBody>
@@ -6739,7 +6946,7 @@
               </a:defRPr>
             </a:pPr>
             <a:r>
-              <a:t>• Hai ngưỡng (minsup, maxsup)</a:t>
+              <a:t>• Duyệt theo mức (level-wise) như Apriori</a:t>
             </a:r>
           </a:p>
           <a:p>
@@ -6754,7 +6961,7 @@
               </a:defRPr>
             </a:pPr>
             <a:r>
-              <a:t>• Loại mọi item phổ biến ngay bước khởi tạo</a:t>
+              <a:t>• Ứng viên sống sót qua prune mà không phổ biến → chính là mRI</a:t>
             </a:r>
           </a:p>
           <a:p>
@@ -6769,7 +6976,7 @@
               </a:defRPr>
             </a:pPr>
             <a:r>
-              <a:t>• Đúng đắn: mọi item hiếm → mọi tập con hiếm (điều kiện PRI tự thoả)</a:t>
+              <a:t>• Itemset hiếm không dùng sinh ứng viên tiếp</a:t>
             </a:r>
           </a:p>
           <a:p>
@@ -6779,12 +6986,12 @@
               </a:spcAft>
               <a:defRPr sz="2000" b="0">
                 <a:solidFill>
-                  <a:srgbClr val="DC2626"/>
-                </a:solidFill>
-              </a:defRPr>
-            </a:pPr>
-            <a:r>
-              <a:t>• Đổi lại: bỏ sót mẫu lai {item hiếm + item phổ biến}</a:t>
+                  <a:srgbClr val="059669"/>
+                </a:solidFill>
+              </a:defRPr>
+            </a:pPr>
+            <a:r>
+              <a:t>• Ví dụ: mRI = {bread}, {lemon, cake}  ✓ khớp bài giảng</a:t>
             </a:r>
           </a:p>
           <a:p>
@@ -6792,14 +6999,14 @@
               <a:spcAft>
                 <a:spcPts val="1200"/>
               </a:spcAft>
-              <a:defRPr sz="2000" b="0">
-                <a:solidFill>
-                  <a:srgbClr val="059669"/>
-                </a:solidFill>
-              </a:defRPr>
-            </a:pPr>
-            <a:r>
-              <a:t>• Ví dụ (1.1, 3.1): 5 PRI  ✓ khớp bài giảng</a:t>
+              <a:defRPr sz="2000" b="1">
+                <a:solidFill>
+                  <a:srgbClr val="DC2626"/>
+                </a:solidFill>
+              </a:defRPr>
+            </a:pPr>
+            <a:r>
+              <a:t>• Nhược: phải duyệt toàn bộ vùng phổ biến</a:t>
             </a:r>
           </a:p>
         </p:txBody>
@@ -6852,7 +7059,7 @@
               </a:defRPr>
             </a:pPr>
             <a:r>
-              <a:t>Mẫu giả: phổ biến ≠ đáng tin</a:t>
+              <a:t>AprioriInverse: thu hẹp ngay từ đầu</a:t>
             </a:r>
           </a:p>
         </p:txBody>
@@ -6883,6 +7090,21 @@
               <a:spcAft>
                 <a:spcPts val="1200"/>
               </a:spcAft>
+              <a:defRPr sz="2000" b="0">
+                <a:solidFill>
+                  <a:srgbClr val="1E1E1E"/>
+                </a:solidFill>
+              </a:defRPr>
+            </a:pPr>
+            <a:r>
+              <a:t>• Hai ngưỡng (minsup, maxsup)</a:t>
+            </a:r>
+          </a:p>
+          <a:p>
+            <a:pPr>
+              <a:spcAft>
+                <a:spcPts val="1200"/>
+              </a:spcAft>
               <a:defRPr sz="2000" b="1">
                 <a:solidFill>
                   <a:srgbClr val="1E1E1E"/>
@@ -6890,7 +7112,7 @@
               </a:defRPr>
             </a:pPr>
             <a:r>
-              <a:t>• {pasta, cake} xuất hiện ở 50% giao dịch</a:t>
+              <a:t>• Loại mọi item phổ biến ngay bước khởi tạo</a:t>
             </a:r>
           </a:p>
           <a:p>
@@ -6905,7 +7127,7 @@
               </a:defRPr>
             </a:pPr>
             <a:r>
-              <a:t>• Nhưng pasta có mặt trong mọi giao dịch</a:t>
+              <a:t>• Đúng đắn: mọi item hiếm → mọi tập con hiếm (điều kiện PRI tự thoả)</a:t>
             </a:r>
           </a:p>
           <a:p>
@@ -6920,7 +7142,7 @@
               </a:defRPr>
             </a:pPr>
             <a:r>
-              <a:t>• Đồng xuất hiện là tất yếu — không có liên hệ thật (spurious)</a:t>
+              <a:t>• Đổi lại: bỏ sót mẫu lai {item hiếm + item phổ biến}</a:t>
             </a:r>
           </a:p>
           <a:p>
@@ -6930,12 +7152,12 @@
               </a:spcAft>
               <a:defRPr sz="2000" b="0">
                 <a:solidFill>
-                  <a:srgbClr val="2563EB"/>
-                </a:solidFill>
-              </a:defRPr>
-            </a:pPr>
-            <a:r>
-              <a:t>• Cần độ đo tương quan để lọc</a:t>
+                  <a:srgbClr val="059669"/>
+                </a:solidFill>
+              </a:defRPr>
+            </a:pPr>
+            <a:r>
+              <a:t>• Ví dụ (1.1, 3.1): 5 PRI  ✓ khớp bài giảng</a:t>
             </a:r>
           </a:p>
         </p:txBody>

</xml_diff>